<commit_message>
Mac Jee p50: corrige contagem de programas e de países nos três formatos
A verificação adversarial pegou dois erros de contagem que estavam nos três
layouts:

- Seis das 55 linhas do arquivo comercial não têm valor atribuído, então os
  US$ 4,6 bn vêm de 49 programas, não de 55. Por BU: Munitions 30 (não 34),
  Energetics 12, Missile 7 (não 9)
- Algumas células trazem dois países ("Turquia/KSA", "MBDA França / UK"), que o
  normalizador colapsava em um. Separando: Munitions 12 países (não 11) e
  Missile 6 (não 5). O total de 21 não muda

A nota de rodapé agora diz explicitamente que há mais seis programas
identificados sem valor, que ficam de fora do número.

Co-Authored-By: Claude Opus 5 <noreply@anthropic.com>
Claude-Session: https://claude.ai/code/session_01WpBz3RSgDKTcBVZLEXuW5T
</commit_message>
<xml_diff>
--- a/macjee/MacJee_p50_BU_size.pptx
+++ b/macjee/MacJee_p50_BU_size.pptx
@@ -1187,7 +1187,7 @@
                 <a:ea typeface="Montserrat" pitchFamily="34" charset="-122"/>
                 <a:cs typeface="Montserrat" pitchFamily="34" charset="-120"/>
               </a:rPr>
-              <a:t>55 named programmes across 21 countries — 1.1x the entire 2026–32 revenue plan, already identified commercially</a:t>
+              <a:t>49 valued programmes across 21 countries — 1.1x the entire 2026–32 revenue plan, already identified commercially</a:t>
             </a:r>
             <a:endParaRPr lang="en-US" sz="1200" dirty="0"/>
           </a:p>
@@ -1531,7 +1531,7 @@
                 <a:ea typeface="Montserrat" pitchFamily="34" charset="-122"/>
                 <a:cs typeface="Montserrat" pitchFamily="34" charset="-120"/>
               </a:rPr>
-              <a:t>Named programmes</a:t>
+              <a:t>Valued programmes</a:t>
             </a:r>
             <a:endParaRPr lang="en-US" sz="760" dirty="0"/>
           </a:p>
@@ -1570,7 +1570,7 @@
                 <a:ea typeface="Montserrat" pitchFamily="34" charset="-122"/>
                 <a:cs typeface="Montserrat" pitchFamily="34" charset="-120"/>
               </a:rPr>
-              <a:t>55</a:t>
+              <a:t>49</a:t>
             </a:r>
             <a:endParaRPr lang="en-US" sz="950" dirty="0"/>
           </a:p>
@@ -2129,7 +2129,7 @@
                 <a:ea typeface="Montserrat" pitchFamily="34" charset="-122"/>
                 <a:cs typeface="Montserrat" pitchFamily="34" charset="-120"/>
               </a:rPr>
-              <a:t>34 programmes  ·  11 countries</a:t>
+              <a:t>30 programmes  ·  12 countries</a:t>
             </a:r>
             <a:endParaRPr lang="en-US" sz="800" dirty="0"/>
           </a:p>
@@ -3053,7 +3053,7 @@
                 <a:ea typeface="Montserrat" pitchFamily="34" charset="-122"/>
                 <a:cs typeface="Montserrat" pitchFamily="34" charset="-120"/>
               </a:rPr>
-              <a:t>9 programmes  ·  5 countries</a:t>
+              <a:t>7 programmes  ·  6 countries</a:t>
             </a:r>
             <a:endParaRPr lang="en-US" sz="800" dirty="0"/>
           </a:p>
@@ -3209,7 +3209,7 @@
                 <a:ea typeface="Montserrat Light" pitchFamily="34" charset="-122"/>
                 <a:cs typeface="Montserrat Light" pitchFamily="34" charset="-120"/>
               </a:rPr>
-              <a:t>Identified opportunity is the total contract value of every signed contract and open commercial opportunity in the Company’s commercial review, at face value and unweighted. Coverage compares it with cumulative gross revenue in the 2026–32 plan.</a:t>
+              <a:t>Identified opportunity is the total contract value of every signed contract and open commercial opportunity in the Company’s commercial review, at face value and unweighted; a further six identified programmes carry no value yet and are excluded. Coverage compares it with cumulative gross revenue in the 2026–32 plan.</a:t>
             </a:r>
             <a:endParaRPr lang="en-US" sz="660" dirty="0"/>
           </a:p>

</xml_diff>